<commit_message>
Reflejar la publicación del repositorio en GitHub
- README: instrucciones de clonado y estado real del repositorio
  (publicado; falta invitar a los integrantes).
- Matriz de requisitos (R24) y registro de progreso actualizados.
- Informe y presentación regenerados con el nuevo próximo paso.

Co-Authored-By: Claude Opus 5.5 <noreply@anthropic.com>
Claude-Session: https://claude.ai/code/session_01JFJDVcK6BUnGbmW9b6Es1K
</commit_message>
<xml_diff>
--- a/slides/presentacion_PSMA00611.pptx
+++ b/slides/presentacion_PSMA00611.pptx
@@ -120,12 +120,12 @@
   <p:extLst>
     <p:ext uri="{521415D9-36F7-43E2-AB2F-B90AF26B5E84}">
       <p14:sectionLst xmlns:p14="http://schemas.microsoft.com/office/powerpoint/2010/main">
-        <p14:section name="Apertura" id="{8896ff7f-753b-3846-890c-5f5c392b3199}">
+        <p14:section name="Apertura" id="{0a2d49a7-09b2-585c-1788-4b3dfee4b590}">
           <p14:sldIdLst>
             <p14:sldId id="256"/>
           </p14:sldIdLst>
         </p14:section>
-        <p14:section name="Problema y diseño" id="{56c0ab83-fb3e-ae5b-9bb3-84cfb14adc39}">
+        <p14:section name="Problema y diseño" id="{474a7b94-b3bb-533d-dcd8-54d08d4ee59e}">
           <p14:sldIdLst>
             <p14:sldId id="257"/>
             <p14:sldId id="258"/>
@@ -134,7 +134,7 @@
             <p14:sldId id="261"/>
           </p14:sldIdLst>
         </p14:section>
-        <p14:section name="Implementación" id="{efe64e37-199b-4111-495b-bbe8b7dba1e5}">
+        <p14:section name="Implementación" id="{3672de7b-729f-3978-9559-28bb821069e9}">
           <p14:sldIdLst>
             <p14:sldId id="262"/>
             <p14:sldId id="263"/>
@@ -142,14 +142,14 @@
             <p14:sldId id="265"/>
           </p14:sldIdLst>
         </p14:section>
-        <p14:section name="Resultados" id="{6a6971ce-eeee-8874-e2a8-991b85a3f360}">
+        <p14:section name="Resultados" id="{d969945d-3c30-912e-9253-436ba60ca8ea}">
           <p14:sldIdLst>
             <p14:sldId id="266"/>
             <p14:sldId id="267"/>
             <p14:sldId id="268"/>
           </p14:sldIdLst>
         </p14:section>
-        <p14:section name="Cierre" id="{a7db1de2-c818-db50-7982-31db910e75a0}">
+        <p14:section name="Cierre" id="{dfe139e6-6bd5-c2c3-47fe-1cc8c8749cca}">
           <p14:sldIdLst>
             <p14:sldId id="269"/>
           </p14:sldIdLst>
@@ -6507,7 +6507,7 @@
                   <a:schemeClr val="bg1"/>
                 </a:solidFill>
               </a:rPr>
-              <a:t>Publicar el repositorio en GitHub</a:t>
+              <a:t>Invitar al equipo al repositorio</a:t>
             </a:r>
             <a:endParaRPr lang="en-US" sz="1600" dirty="0"/>
           </a:p>

</xml_diff>

<commit_message>
Avance del PAC: índices, diagramas, trabajo en equipo y prompts
- Documento de avance reescrito en un tono más cercano, con índice
  general, índice de figuras e índice de tablas, 19 figuras (16 diagramas
  nuevos generados por src/aerolinea/figuras_avance.py), sección de trabajo
  en equipo, árbol de archivos (anexo A), prompts literales (anexo B) y
  borrador de declaración de uso de IA (anexo C).
- docs/equipo/prompts.json: prompts y respuestas copiados del registro de
  la sesión, sin editar.
- Carátulas del informe, del avance y de la presentación con los
  integrantes, los docentes y el líder; registro de aportes con la
  declaración del equipo.
- Los índices del DOCX se guardan ya calculados y se ven sin actualizar
  campos; el informe final titula «Índice» a su tabla de contenido.

Co-Authored-By: Claude Opus 5.5 <noreply@anthropic.com>
Claude-Session: https://claude.ai/code/session_01JFJDVcK6BUnGbmW9b6Es1K
</commit_message>
<xml_diff>
--- a/slides/presentacion_PSMA00611.pptx
+++ b/slides/presentacion_PSMA00611.pptx
@@ -120,12 +120,12 @@
   <p:extLst>
     <p:ext uri="{521415D9-36F7-43E2-AB2F-B90AF26B5E84}">
       <p14:sectionLst xmlns:p14="http://schemas.microsoft.com/office/powerpoint/2010/main">
-        <p14:section name="Apertura" id="{0a2d49a7-09b2-585c-1788-4b3dfee4b590}">
+        <p14:section name="Apertura" id="{ed95e5e1-0d51-4478-401d-0c91d0e3f36b}">
           <p14:sldIdLst>
             <p14:sldId id="256"/>
           </p14:sldIdLst>
         </p14:section>
-        <p14:section name="Problema y diseño" id="{474a7b94-b3bb-533d-dcd8-54d08d4ee59e}">
+        <p14:section name="Problema y diseño" id="{f98dced4-f244-fe55-0f80-b989f7b31308}">
           <p14:sldIdLst>
             <p14:sldId id="257"/>
             <p14:sldId id="258"/>
@@ -134,7 +134,7 @@
             <p14:sldId id="261"/>
           </p14:sldIdLst>
         </p14:section>
-        <p14:section name="Implementación" id="{3672de7b-729f-3978-9559-28bb821069e9}">
+        <p14:section name="Implementación" id="{0beb4a12-0013-f301-d448-c21897e5b3f5}">
           <p14:sldIdLst>
             <p14:sldId id="262"/>
             <p14:sldId id="263"/>
@@ -142,14 +142,14 @@
             <p14:sldId id="265"/>
           </p14:sldIdLst>
         </p14:section>
-        <p14:section name="Resultados" id="{d969945d-3c30-912e-9253-436ba60ca8ea}">
+        <p14:section name="Resultados" id="{1c3c05a4-1bb4-dc49-ff4b-2d4a345982fb}">
           <p14:sldIdLst>
             <p14:sldId id="266"/>
             <p14:sldId id="267"/>
             <p14:sldId id="268"/>
           </p14:sldIdLst>
         </p14:section>
-        <p14:section name="Cierre" id="{dfe139e6-6bd5-c2c3-47fe-1cc8c8749cca}">
+        <p14:section name="Cierre" id="{d24b645d-6eef-e4d7-0247-1aca53e8b921}">
           <p14:sldIdLst>
             <p14:sldId id="269"/>
           </p14:sldIdLst>
@@ -3411,8 +3411,8 @@
         </p:nvSpPr>
         <p:spPr>
           <a:xfrm>
-            <a:off x="731520" y="5120640"/>
-            <a:ext cx="10515600" cy="1097280"/>
+            <a:off x="731520" y="4892040"/>
+            <a:ext cx="10789920" cy="1508760"/>
           </a:xfrm>
           <a:prstGeom prst="rect">
             <a:avLst/>
@@ -3431,14 +3431,14 @@
               <a:buNone/>
             </a:pPr>
             <a:r>
-              <a:rPr lang="en-US" sz="1400" dirty="0">
+              <a:rPr lang="en-US" sz="1300" dirty="0">
                 <a:solidFill>
                   <a:schemeClr val="bg1"/>
                 </a:solidFill>
               </a:rPr>
               <a:t>Gestión de datos y bases de datos con SQL (PSMA00611)</a:t>
             </a:r>
-            <a:endParaRPr lang="en-US" sz="1400" dirty="0"/>
+            <a:endParaRPr lang="en-US" sz="1300" dirty="0"/>
           </a:p>
           <a:p>
             <a:pPr indent="0" marL="0">
@@ -3448,14 +3448,14 @@
               <a:buNone/>
             </a:pPr>
             <a:r>
-              <a:rPr lang="en-US" sz="1400" dirty="0">
+              <a:rPr lang="en-US" sz="1300" dirty="0">
                 <a:solidFill>
                   <a:schemeClr val="bg1"/>
                 </a:solidFill>
               </a:rPr>
               <a:t>Maestría en Ciencia de Datos · Escuela de Posgrado · Universidad Continental</a:t>
             </a:r>
-            <a:endParaRPr lang="en-US" sz="1400" dirty="0"/>
+            <a:endParaRPr lang="en-US" sz="1300" dirty="0"/>
           </a:p>
           <a:p>
             <a:pPr indent="0" marL="0">
@@ -3465,14 +3465,31 @@
               <a:buNone/>
             </a:pPr>
             <a:r>
-              <a:rPr lang="en-US" sz="1400" dirty="0">
+              <a:rPr lang="en-US" sz="1300" dirty="0">
                 <a:solidFill>
                   <a:schemeClr val="bg1"/>
                 </a:solidFill>
               </a:rPr>
-              <a:t>Equipo: [POR COMPLETAR]   ·   Docente: [POR COMPLETAR]</a:t>
-            </a:r>
-            <a:endParaRPr lang="en-US" sz="1400" dirty="0"/>
+              <a:t>Equipo: Carlos Veliz de Villa Aguirre · Elias Sifuentes Valles · Carlos De los Ríos De la Roca (líder)</a:t>
+            </a:r>
+            <a:endParaRPr lang="en-US" sz="1300" dirty="0"/>
+          </a:p>
+          <a:p>
+            <a:pPr indent="0" marL="0">
+              <a:spcAft>
+                <a:spcPts val="400"/>
+              </a:spcAft>
+              <a:buNone/>
+            </a:pPr>
+            <a:r>
+              <a:rPr lang="en-US" sz="1300" dirty="0">
+                <a:solidFill>
+                  <a:schemeClr val="bg1"/>
+                </a:solidFill>
+              </a:rPr>
+              <a:t>Docentes: Walter Alejandro Silva Sotillo y Max Leoncio Mucha Morales</a:t>
+            </a:r>
+            <a:endParaRPr lang="en-US" sz="1300" dirty="0"/>
           </a:p>
         </p:txBody>
       </p:sp>

</xml_diff>